<commit_message>
feat: incorporar materiais do OneDrive ao 4 semestre
Slides, listas e Desafio 01 (NUMBANK) de Mobile e Web .NET; apostilas,
questoes CPM e leituras de Projetos Agil; aulas 02-06 e roteiros de
laboratorio de PBD; Questoes CQA (Tomos 01-18 e Formacao Geral) em
Material de Apoio. Aulas 01 atualizadas para a versao mais recente.

Co-Authored-By: Claude Opus 5.5 <noreply@anthropic.com>
</commit_message>
<xml_diff>
--- a/01 - CURSO ADS/4° Semestre (Atual)/Disciplinas Presenciais/ED/Desenvolvimento Mobile/Slides/Aula 01 - JavaScript Básico.pptx
+++ b/01 - CURSO ADS/4° Semestre (Atual)/Disciplinas Presenciais/ED/Desenvolvimento Mobile/Slides/Aula 01 - JavaScript Básico.pptx
@@ -2,44 +2,44 @@
 <file path=ppt/presentation.xml><?xml version="1.0" encoding="utf-8"?>
 <p:presentation xmlns:a="http://schemas.openxmlformats.org/drawingml/2006/main" xmlns:r="http://schemas.openxmlformats.org/officeDocument/2006/relationships" xmlns:p="http://schemas.openxmlformats.org/presentationml/2006/main" saveSubsetFonts="1" autoCompressPictures="0">
   <p:sldMasterIdLst>
-    <p:sldMasterId id="2147483648" r:id="rId1"/>
+    <p:sldMasterId id="2147483648" r:id="rId4"/>
   </p:sldMasterIdLst>
   <p:notesMasterIdLst>
-    <p:notesMasterId r:id="rId34"/>
+    <p:notesMasterId r:id="rId37"/>
   </p:notesMasterIdLst>
   <p:sldIdLst>
-    <p:sldId id="289" r:id="rId2"/>
-    <p:sldId id="285" r:id="rId3"/>
-    <p:sldId id="286" r:id="rId4"/>
-    <p:sldId id="287" r:id="rId5"/>
-    <p:sldId id="288" r:id="rId6"/>
-    <p:sldId id="284" r:id="rId7"/>
-    <p:sldId id="258" r:id="rId8"/>
-    <p:sldId id="259" r:id="rId9"/>
-    <p:sldId id="260" r:id="rId10"/>
-    <p:sldId id="261" r:id="rId11"/>
-    <p:sldId id="262" r:id="rId12"/>
-    <p:sldId id="263" r:id="rId13"/>
-    <p:sldId id="264" r:id="rId14"/>
-    <p:sldId id="265" r:id="rId15"/>
-    <p:sldId id="266" r:id="rId16"/>
-    <p:sldId id="267" r:id="rId17"/>
-    <p:sldId id="268" r:id="rId18"/>
-    <p:sldId id="269" r:id="rId19"/>
-    <p:sldId id="270" r:id="rId20"/>
-    <p:sldId id="271" r:id="rId21"/>
-    <p:sldId id="272" r:id="rId22"/>
-    <p:sldId id="273" r:id="rId23"/>
-    <p:sldId id="274" r:id="rId24"/>
-    <p:sldId id="275" r:id="rId25"/>
-    <p:sldId id="276" r:id="rId26"/>
-    <p:sldId id="277" r:id="rId27"/>
-    <p:sldId id="278" r:id="rId28"/>
-    <p:sldId id="279" r:id="rId29"/>
-    <p:sldId id="280" r:id="rId30"/>
-    <p:sldId id="281" r:id="rId31"/>
-    <p:sldId id="282" r:id="rId32"/>
-    <p:sldId id="283" r:id="rId33"/>
+    <p:sldId id="289" r:id="rId5"/>
+    <p:sldId id="285" r:id="rId6"/>
+    <p:sldId id="286" r:id="rId7"/>
+    <p:sldId id="287" r:id="rId8"/>
+    <p:sldId id="288" r:id="rId9"/>
+    <p:sldId id="284" r:id="rId10"/>
+    <p:sldId id="258" r:id="rId11"/>
+    <p:sldId id="259" r:id="rId12"/>
+    <p:sldId id="260" r:id="rId13"/>
+    <p:sldId id="261" r:id="rId14"/>
+    <p:sldId id="262" r:id="rId15"/>
+    <p:sldId id="263" r:id="rId16"/>
+    <p:sldId id="264" r:id="rId17"/>
+    <p:sldId id="265" r:id="rId18"/>
+    <p:sldId id="266" r:id="rId19"/>
+    <p:sldId id="267" r:id="rId20"/>
+    <p:sldId id="268" r:id="rId21"/>
+    <p:sldId id="269" r:id="rId22"/>
+    <p:sldId id="270" r:id="rId23"/>
+    <p:sldId id="271" r:id="rId24"/>
+    <p:sldId id="272" r:id="rId25"/>
+    <p:sldId id="273" r:id="rId26"/>
+    <p:sldId id="274" r:id="rId27"/>
+    <p:sldId id="275" r:id="rId28"/>
+    <p:sldId id="276" r:id="rId29"/>
+    <p:sldId id="277" r:id="rId30"/>
+    <p:sldId id="278" r:id="rId31"/>
+    <p:sldId id="279" r:id="rId32"/>
+    <p:sldId id="280" r:id="rId33"/>
+    <p:sldId id="281" r:id="rId34"/>
+    <p:sldId id="282" r:id="rId35"/>
+    <p:sldId id="283" r:id="rId36"/>
   </p:sldIdLst>
   <p:sldSz cx="12192000" cy="6858000"/>
   <p:notesSz cx="6858000" cy="12192000"/>
@@ -135,6 +135,11 @@
       </a:defRPr>
     </a:lvl9pPr>
   </p:defaultTextStyle>
+  <p:extLst>
+    <p:ext uri="{EFAFB233-063F-42B5-8137-9DF3F51BA10A}">
+      <p15:sldGuideLst xmlns:p15="http://schemas.microsoft.com/office/powerpoint/2012/main"/>
+    </p:ext>
+  </p:extLst>
 </p:presentation>
 </file>
 
@@ -220,7 +225,7 @@
           <a:p>
             <a:fld id="{5282F153-3F37-0F45-9E97-73ACFA13230C}" type="datetimeFigureOut">
               <a:rPr lang="en-US"/>
-              <a:t>8/6/2026</a:t>
+              <a:t>8/31/2026</a:t>
             </a:fld>
             <a:endParaRPr lang="en-US"/>
           </a:p>
@@ -378,7 +383,7 @@
           <a:p>
             <a:fld id="{CE5E9CC1-C706-0F49-92D6-E571CC5EEA8F}" type="slidenum">
               <a:rPr lang="en-US"/>
-              <a:t>‹#›</a:t>
+              <a:t>‹nº›</a:t>
             </a:fld>
             <a:endParaRPr lang="en-US"/>
           </a:p>
@@ -17277,18 +17282,57 @@
 </file>
 
 <file path=customXml/item1.xml><?xml version="1.0" encoding="utf-8"?>
-<ct:contentTypeSchema xmlns:ct="http://schemas.microsoft.com/office/2006/metadata/contentType" xmlns:ma="http://schemas.microsoft.com/office/2006/metadata/properties/metaAttributes" ct:_="" ma:_="" ma:contentTypeName="Documento" ma:contentTypeID="0x010100CFEFA75D999B6A458895E2D1D4CAD7D5" ma:contentTypeVersion="0" ma:contentTypeDescription="Crie um novo documento." ma:contentTypeScope="" ma:versionID="3b4c792a5a80c23c75d0bfb6a57a9e10">
-  <xsd:schema xmlns:xsd="http://www.w3.org/2001/XMLSchema" xmlns:xs="http://www.w3.org/2001/XMLSchema" xmlns:p="http://schemas.microsoft.com/office/2006/metadata/properties" targetNamespace="http://schemas.microsoft.com/office/2006/metadata/properties" ma:root="true" ma:fieldsID="059dbc040a3f85ddd093e31795c9c73e">
+<p:properties xmlns:p="http://schemas.microsoft.com/office/2006/metadata/properties" xmlns:xsi="http://www.w3.org/2001/XMLSchema-instance" xmlns:pc="http://schemas.microsoft.com/office/infopath/2007/PartnerControls">
+  <documentManagement/>
+</p:properties>
+</file>
+
+<file path=customXml/item2.xml><?xml version="1.0" encoding="utf-8"?>
+<?mso-contentType ?>
+<FormTemplates xmlns="http://schemas.microsoft.com/sharepoint/v3/contenttype/forms">
+  <Display>DocumentLibraryForm</Display>
+  <Edit>DocumentLibraryForm</Edit>
+  <New>DocumentLibraryForm</New>
+</FormTemplates>
+</file>
+
+<file path=customXml/item3.xml><?xml version="1.0" encoding="utf-8"?>
+<ct:contentTypeSchema xmlns:ct="http://schemas.microsoft.com/office/2006/metadata/contentType" xmlns:ma="http://schemas.microsoft.com/office/2006/metadata/properties/metaAttributes" ct:_="" ma:_="" ma:contentTypeName="Document" ma:contentTypeID="0x010100CFEFA75D999B6A458895E2D1D4CAD7D5" ma:contentTypeVersion="3" ma:contentTypeDescription="Create a new document." ma:contentTypeScope="" ma:versionID="a4d8d2aebad61fcaa853fd63fa487561">
+  <xsd:schema xmlns:xsd="http://www.w3.org/2001/XMLSchema" xmlns:xs="http://www.w3.org/2001/XMLSchema" xmlns:p="http://schemas.microsoft.com/office/2006/metadata/properties" xmlns:ns2="50a733fb-aa42-4bdb-a9d1-5f2a081c7e8f" targetNamespace="http://schemas.microsoft.com/office/2006/metadata/properties" ma:root="true" ma:fieldsID="81b16acfd845e6c242d850537546584a" ns2:_="">
+    <xsd:import namespace="50a733fb-aa42-4bdb-a9d1-5f2a081c7e8f"/>
     <xsd:element name="properties">
       <xsd:complexType>
         <xsd:sequence>
           <xsd:element name="documentManagement">
             <xsd:complexType>
-              <xsd:all/>
+              <xsd:all>
+                <xsd:element ref="ns2:MediaServiceMetadata" minOccurs="0"/>
+                <xsd:element ref="ns2:MediaServiceFastMetadata" minOccurs="0"/>
+                <xsd:element ref="ns2:MediaServiceSearchProperties" minOccurs="0"/>
+              </xsd:all>
             </xsd:complexType>
           </xsd:element>
         </xsd:sequence>
       </xsd:complexType>
+    </xsd:element>
+  </xsd:schema>
+  <xsd:schema xmlns:xsd="http://www.w3.org/2001/XMLSchema" xmlns:xs="http://www.w3.org/2001/XMLSchema" xmlns:dms="http://schemas.microsoft.com/office/2006/documentManagement/types" xmlns:pc="http://schemas.microsoft.com/office/infopath/2007/PartnerControls" targetNamespace="50a733fb-aa42-4bdb-a9d1-5f2a081c7e8f" elementFormDefault="qualified">
+    <xsd:import namespace="http://schemas.microsoft.com/office/2006/documentManagement/types"/>
+    <xsd:import namespace="http://schemas.microsoft.com/office/infopath/2007/PartnerControls"/>
+    <xsd:element name="MediaServiceMetadata" ma:index="8" nillable="true" ma:displayName="MediaServiceMetadata" ma:hidden="true" ma:internalName="MediaServiceMetadata" ma:readOnly="true">
+      <xsd:simpleType>
+        <xsd:restriction base="dms:Note"/>
+      </xsd:simpleType>
+    </xsd:element>
+    <xsd:element name="MediaServiceFastMetadata" ma:index="9" nillable="true" ma:displayName="MediaServiceFastMetadata" ma:hidden="true" ma:internalName="MediaServiceFastMetadata" ma:readOnly="true">
+      <xsd:simpleType>
+        <xsd:restriction base="dms:Note"/>
+      </xsd:simpleType>
+    </xsd:element>
+    <xsd:element name="MediaServiceSearchProperties" ma:index="10" nillable="true" ma:displayName="MediaServiceSearchProperties" ma:hidden="true" ma:internalName="MediaServiceSearchProperties" ma:readOnly="true">
+      <xsd:simpleType>
+        <xsd:restriction base="dms:Note"/>
+      </xsd:simpleType>
     </xsd:element>
   </xsd:schema>
   <xsd:schema xmlns="http://schemas.openxmlformats.org/package/2006/metadata/core-properties" xmlns:xsd="http://www.w3.org/2001/XMLSchema" xmlns:xsi="http://www.w3.org/2001/XMLSchema-instance" xmlns:dc="http://purl.org/dc/elements/1.1/" xmlns:dcterms="http://purl.org/dc/terms/" xmlns:odoc="http://schemas.microsoft.com/internal/obd" targetNamespace="http://schemas.openxmlformats.org/package/2006/metadata/core-properties" elementFormDefault="qualified" attributeFormDefault="unqualified" blockDefault="#all">
@@ -17300,8 +17344,8 @@
         <xsd:element ref="dc:creator" minOccurs="0" maxOccurs="1"/>
         <xsd:element ref="dcterms:created" minOccurs="0" maxOccurs="1"/>
         <xsd:element ref="dc:identifier" minOccurs="0" maxOccurs="1"/>
-        <xsd:element name="contentType" minOccurs="0" maxOccurs="1" type="xsd:string" ma:index="0" ma:displayName="Tipo de Conteúdo"/>
-        <xsd:element ref="dc:title" minOccurs="0" maxOccurs="1" ma:index="4" ma:displayName="Título"/>
+        <xsd:element name="contentType" minOccurs="0" maxOccurs="1" type="xsd:string" ma:index="0" ma:displayName="Content Type"/>
+        <xsd:element ref="dc:title" minOccurs="0" maxOccurs="1" ma:index="4" ma:displayName="Title"/>
         <xsd:element ref="dc:subject" minOccurs="0" maxOccurs="1"/>
         <xsd:element ref="dc:description" minOccurs="0" maxOccurs="1"/>
         <xsd:element name="keywords" minOccurs="0" maxOccurs="1" type="xsd:string"/>
@@ -17390,29 +17434,23 @@
 </ct:contentTypeSchema>
 </file>
 
-<file path=customXml/item2.xml><?xml version="1.0" encoding="utf-8"?>
-<?mso-contentType ?>
-<FormTemplates xmlns="http://schemas.microsoft.com/sharepoint/v3/contenttype/forms">
-  <Display>DocumentLibraryForm</Display>
-  <Edit>DocumentLibraryForm</Edit>
-  <New>DocumentLibraryForm</New>
-</FormTemplates>
-</file>
-
-<file path=customXml/item3.xml><?xml version="1.0" encoding="utf-8"?>
-<p:properties xmlns:p="http://schemas.microsoft.com/office/2006/metadata/properties" xmlns:xsi="http://www.w3.org/2001/XMLSchema-instance" xmlns:pc="http://schemas.microsoft.com/office/infopath/2007/PartnerControls">
-  <documentManagement/>
-</p:properties>
-</file>
-
 <file path=customXml/itemProps1.xml><?xml version="1.0" encoding="utf-8"?>
-<ds:datastoreItem xmlns:ds="http://schemas.openxmlformats.org/officeDocument/2006/customXml" ds:itemID="{09FC00E0-BF91-4744-AE14-0134034537E3}"/>
+<ds:datastoreItem xmlns:ds="http://schemas.openxmlformats.org/officeDocument/2006/customXml" ds:itemID="{DD3B3FC5-46E5-485E-9870-B0A0AE97ED05}">
+  <ds:schemaRefs>
+    <ds:schemaRef ds:uri="http://schemas.microsoft.com/office/2006/metadata/properties"/>
+    <ds:schemaRef ds:uri="http://schemas.microsoft.com/office/infopath/2007/PartnerControls"/>
+  </ds:schemaRefs>
+</ds:datastoreItem>
 </file>
 
 <file path=customXml/itemProps2.xml><?xml version="1.0" encoding="utf-8"?>
-<ds:datastoreItem xmlns:ds="http://schemas.openxmlformats.org/officeDocument/2006/customXml" ds:itemID="{5E9E7E90-D662-4A69-A3A7-0DA0D2218CAF}"/>
+<ds:datastoreItem xmlns:ds="http://schemas.openxmlformats.org/officeDocument/2006/customXml" ds:itemID="{5E9E7E90-D662-4A69-A3A7-0DA0D2218CAF}">
+  <ds:schemaRefs>
+    <ds:schemaRef ds:uri="http://schemas.microsoft.com/sharepoint/v3/contenttype/forms"/>
+  </ds:schemaRefs>
+</ds:datastoreItem>
 </file>
 
 <file path=customXml/itemProps3.xml><?xml version="1.0" encoding="utf-8"?>
-<ds:datastoreItem xmlns:ds="http://schemas.openxmlformats.org/officeDocument/2006/customXml" ds:itemID="{DD3B3FC5-46E5-485E-9870-B0A0AE97ED05}"/>
+<ds:datastoreItem xmlns:ds="http://schemas.openxmlformats.org/officeDocument/2006/customXml" ds:itemID="{89F846BB-5D5A-4629-A2B6-A6C5A2CD3225}"/>
 </file>
</xml_diff>